<commit_message>
English-only web deployed: screens, GIF and deck refreshed
make deploy-web from d67c035 (API unchanged, revision 00009-cww); make smoke
and make console-live pass. make screens re-captured docs/img/screens/ and
docs/img/demo.gif without the language toggle; make deck rebuilt the
submission deck with them. PROGRESS row 15 done.
</commit_message>
<xml_diff>
--- a/submission/PauseGuard_Submission.pptx
+++ b/submission/PauseGuard_Submission.pptx
@@ -11014,7 +11014,7 @@
                 <a:ea typeface="Google Sans Flex"/>
                 <a:cs typeface="Google Sans Flex"/>
               </a:rPr>
-              <a:t>The customer sees exactly why: numbered boxes on their own screenshot, in English or Chinese. The analyst gets a live case file and can block the scammer for every customer in one click.</a:t>
+              <a:t>The customer sees exactly why: numbered boxes on their own screenshot, in plain English. The analyst gets a live case file and can block the scammer for every customer in one click.</a:t>
             </a:r>
           </a:p>
         </p:txBody>
@@ -11827,7 +11827,7 @@
                 <a:ea typeface="Google Sans Flex"/>
                 <a:cs typeface="Google Sans Flex"/>
               </a:rPr>
-              <a:t>Explanations in English or Chinese; no blame, plain language</a:t>
+              <a:t>Plain-English explanations; no blame</a:t>
             </a:r>
           </a:p>
           <a:p>
@@ -12827,7 +12827,7 @@
                 <a:ea typeface="Google Sans Flex"/>
                 <a:cs typeface="Google Sans Flex"/>
               </a:rPr>
-              <a:t>The same RED for Mrs Tan, in Chinese</a:t>
+              <a:t>The red flags, numbered on her own screenshot</a:t>
             </a:r>
           </a:p>
         </p:txBody>

</xml_diff>